<commit_message>
Update presentation with new project screenshots and descriptions
Add six new project screenshots with captions to the presentation slides and update metadata.

Replit-Commit-Author: Agent
Replit-Commit-Session-Id: 90a5a383-1c0d-45f3-a9ed-6b2404e856d1
Replit-Commit-Checkpoint-Type: full_checkpoint
Replit-Commit-Event-Id: 89c7d0bb-caf5-4284-9c7a-3cd6f2fcccc7
Replit-Commit-Screenshot-Url: https://storage.googleapis.com/screenshot-production-us-central1/632933d6-4a17-4d84-975b-57cc17d89557/90a5a383-1c0d-45f3-a9ed-6b2404e856d1/89cGy2K
Replit-Helium-Checkpoint-Created: true
</commit_message>
<xml_diff>
--- a/attached_assets/LAB_Project_Presentation.pptx
+++ b/attached_assets/LAB_Project_Presentation.pptx
@@ -3603,8 +3603,8 @@
         </p:nvSpPr>
         <p:spPr>
           <a:xfrm>
-            <a:off x="731520" y="1920240"/>
-            <a:ext cx="5394960" cy="2148840"/>
+            <a:off x="502920" y="1874519"/>
+            <a:ext cx="3657600" cy="1965960"/>
           </a:xfrm>
           <a:prstGeom prst="rect">
             <a:avLst/>
@@ -3642,7 +3642,7 @@
       </p:sp>
       <p:pic>
         <p:nvPicPr>
-          <p:cNvPr id="8" name="Picture 7" descr="image_1776638568991.png"/>
+          <p:cNvPr id="8" name="Picture 7" descr="Screenshot_(1320)_1778766425623.png"/>
           <p:cNvPicPr>
             <a:picLocks noChangeAspect="1"/>
           </p:cNvPicPr>
@@ -3656,8 +3656,8 @@
         </p:blipFill>
         <p:spPr>
           <a:xfrm>
-            <a:off x="777240" y="1965960"/>
-            <a:ext cx="5303520" cy="2057400"/>
+            <a:off x="539496" y="1911095"/>
+            <a:ext cx="3584448" cy="1892808"/>
           </a:xfrm>
           <a:prstGeom prst="rect">
             <a:avLst/>
@@ -3666,14 +3666,49 @@
       </p:pic>
       <p:sp>
         <p:nvSpPr>
-          <p:cNvPr id="9" name="Rectangle 8"/>
+          <p:cNvPr id="9" name="TextBox 8"/>
+          <p:cNvSpPr txBox="1"/>
+          <p:nvPr/>
+        </p:nvSpPr>
+        <p:spPr>
+          <a:xfrm>
+            <a:off x="502920" y="3858767"/>
+            <a:ext cx="3657600" cy="274320"/>
+          </a:xfrm>
+          <a:prstGeom prst="rect">
+            <a:avLst/>
+          </a:prstGeom>
+          <a:noFill/>
+        </p:spPr>
+        <p:txBody>
+          <a:bodyPr wrap="square" lIns="0" rIns="0" tIns="0" bIns="0">
+            <a:spAutoFit/>
+          </a:bodyPr>
+          <a:lstStyle/>
+          <a:p>
+            <a:pPr algn="ctr"/>
+            <a:r>
+              <a:rPr sz="1200" b="1">
+                <a:solidFill>
+                  <a:srgbClr val="FFFFFF"/>
+                </a:solidFill>
+                <a:latin typeface="Calibri"/>
+              </a:rPr>
+              <a:t>Login Screen</a:t>
+            </a:r>
+          </a:p>
+        </p:txBody>
+      </p:sp>
+      <p:sp>
+        <p:nvSpPr>
+          <p:cNvPr id="10" name="Rectangle 9"/>
           <p:cNvSpPr/>
           <p:nvPr/>
         </p:nvSpPr>
         <p:spPr>
           <a:xfrm>
-            <a:off x="6217920" y="1920240"/>
-            <a:ext cx="5394960" cy="2148840"/>
+            <a:off x="4251960" y="1874519"/>
+            <a:ext cx="3657600" cy="1965960"/>
           </a:xfrm>
           <a:prstGeom prst="rect">
             <a:avLst/>
@@ -3711,7 +3746,7 @@
       </p:sp>
       <p:pic>
         <p:nvPicPr>
-          <p:cNvPr id="10" name="Picture 9" descr="image_1776634602123.png"/>
+          <p:cNvPr id="11" name="Picture 10" descr="Screenshot_(1321)_1778766425625.png"/>
           <p:cNvPicPr>
             <a:picLocks noChangeAspect="1"/>
           </p:cNvPicPr>
@@ -3725,8 +3760,8 @@
         </p:blipFill>
         <p:spPr>
           <a:xfrm>
-            <a:off x="6263640" y="1965960"/>
-            <a:ext cx="5303520" cy="2057400"/>
+            <a:off x="4288536" y="1911095"/>
+            <a:ext cx="3584448" cy="1892808"/>
           </a:xfrm>
           <a:prstGeom prst="rect">
             <a:avLst/>
@@ -3735,14 +3770,49 @@
       </p:pic>
       <p:sp>
         <p:nvSpPr>
-          <p:cNvPr id="11" name="Rectangle 10"/>
+          <p:cNvPr id="12" name="TextBox 11"/>
+          <p:cNvSpPr txBox="1"/>
+          <p:nvPr/>
+        </p:nvSpPr>
+        <p:spPr>
+          <a:xfrm>
+            <a:off x="4251960" y="3858767"/>
+            <a:ext cx="3657600" cy="274320"/>
+          </a:xfrm>
+          <a:prstGeom prst="rect">
+            <a:avLst/>
+          </a:prstGeom>
+          <a:noFill/>
+        </p:spPr>
+        <p:txBody>
+          <a:bodyPr wrap="square" lIns="0" rIns="0" tIns="0" bIns="0">
+            <a:spAutoFit/>
+          </a:bodyPr>
+          <a:lstStyle/>
+          <a:p>
+            <a:pPr algn="ctr"/>
+            <a:r>
+              <a:rPr sz="1200" b="1">
+                <a:solidFill>
+                  <a:srgbClr val="FFFFFF"/>
+                </a:solidFill>
+                <a:latin typeface="Calibri"/>
+              </a:rPr>
+              <a:t>Home Dashboard</a:t>
+            </a:r>
+          </a:p>
+        </p:txBody>
+      </p:sp>
+      <p:sp>
+        <p:nvSpPr>
+          <p:cNvPr id="13" name="Rectangle 12"/>
           <p:cNvSpPr/>
           <p:nvPr/>
         </p:nvSpPr>
         <p:spPr>
           <a:xfrm>
-            <a:off x="731520" y="4206240"/>
-            <a:ext cx="5394960" cy="2148840"/>
+            <a:off x="8001000" y="1874519"/>
+            <a:ext cx="3657600" cy="1965960"/>
           </a:xfrm>
           <a:prstGeom prst="rect">
             <a:avLst/>
@@ -3780,7 +3850,7 @@
       </p:sp>
       <p:pic>
         <p:nvPicPr>
-          <p:cNvPr id="12" name="Picture 11" descr="image_1776633549672.png"/>
+          <p:cNvPr id="14" name="Picture 13" descr="Screenshot_(1325)_1778766425632.png"/>
           <p:cNvPicPr>
             <a:picLocks noChangeAspect="1"/>
           </p:cNvPicPr>
@@ -3794,8 +3864,8 @@
         </p:blipFill>
         <p:spPr>
           <a:xfrm>
-            <a:off x="777240" y="4251960"/>
-            <a:ext cx="5303520" cy="2057400"/>
+            <a:off x="8037576" y="1911095"/>
+            <a:ext cx="3584448" cy="1892808"/>
           </a:xfrm>
           <a:prstGeom prst="rect">
             <a:avLst/>
@@ -3804,14 +3874,49 @@
       </p:pic>
       <p:sp>
         <p:nvSpPr>
-          <p:cNvPr id="13" name="Rectangle 12"/>
+          <p:cNvPr id="15" name="TextBox 14"/>
+          <p:cNvSpPr txBox="1"/>
+          <p:nvPr/>
+        </p:nvSpPr>
+        <p:spPr>
+          <a:xfrm>
+            <a:off x="8001000" y="3858767"/>
+            <a:ext cx="3657600" cy="274320"/>
+          </a:xfrm>
+          <a:prstGeom prst="rect">
+            <a:avLst/>
+          </a:prstGeom>
+          <a:noFill/>
+        </p:spPr>
+        <p:txBody>
+          <a:bodyPr wrap="square" lIns="0" rIns="0" tIns="0" bIns="0">
+            <a:spAutoFit/>
+          </a:bodyPr>
+          <a:lstStyle/>
+          <a:p>
+            <a:pPr algn="ctr"/>
+            <a:r>
+              <a:rPr sz="1200" b="1">
+                <a:solidFill>
+                  <a:srgbClr val="FFFFFF"/>
+                </a:solidFill>
+                <a:latin typeface="Calibri"/>
+              </a:rPr>
+              <a:t>BMI Fitness Profile</a:t>
+            </a:r>
+          </a:p>
+        </p:txBody>
+      </p:sp>
+      <p:sp>
+        <p:nvSpPr>
+          <p:cNvPr id="16" name="Rectangle 15"/>
           <p:cNvSpPr/>
           <p:nvPr/>
         </p:nvSpPr>
         <p:spPr>
           <a:xfrm>
-            <a:off x="6217920" y="4206240"/>
-            <a:ext cx="5394960" cy="2148840"/>
+            <a:off x="502920" y="4343399"/>
+            <a:ext cx="3657600" cy="1965960"/>
           </a:xfrm>
           <a:prstGeom prst="rect">
             <a:avLst/>
@@ -3849,7 +3954,7 @@
       </p:sp>
       <p:pic>
         <p:nvPicPr>
-          <p:cNvPr id="14" name="Picture 13" descr="image_1776633503273.png"/>
+          <p:cNvPr id="17" name="Picture 16" descr="Screenshot_(1322)_1778766425627.png"/>
           <p:cNvPicPr>
             <a:picLocks noChangeAspect="1"/>
           </p:cNvPicPr>
@@ -3863,8 +3968,8 @@
         </p:blipFill>
         <p:spPr>
           <a:xfrm>
-            <a:off x="6263640" y="4251960"/>
-            <a:ext cx="5303520" cy="2057400"/>
+            <a:off x="539496" y="4379975"/>
+            <a:ext cx="3584448" cy="1892808"/>
           </a:xfrm>
           <a:prstGeom prst="rect">
             <a:avLst/>
@@ -3873,14 +3978,14 @@
       </p:pic>
       <p:sp>
         <p:nvSpPr>
-          <p:cNvPr id="15" name="TextBox 14"/>
+          <p:cNvPr id="18" name="TextBox 17"/>
           <p:cNvSpPr txBox="1"/>
           <p:nvPr/>
         </p:nvSpPr>
         <p:spPr>
           <a:xfrm>
-            <a:off x="731520" y="6400800"/>
-            <a:ext cx="10698480" cy="274320"/>
+            <a:off x="502920" y="6327647"/>
+            <a:ext cx="3657600" cy="274320"/>
           </a:xfrm>
           <a:prstGeom prst="rect">
             <a:avLst/>
@@ -3895,20 +4000,228 @@
           <a:p>
             <a:pPr algn="ctr"/>
             <a:r>
-              <a:rPr sz="1100" b="0">
-                <a:solidFill>
-                  <a:srgbClr val="A1A1AA"/>
-                </a:solidFill>
-                <a:latin typeface="Calibri"/>
-              </a:rPr>
-              <a:t>Screenshots from the LAB project (database, admin panel, app UI)</a:t>
-            </a:r>
-          </a:p>
-        </p:txBody>
-      </p:sp>
-      <p:sp>
-        <p:nvSpPr>
-          <p:cNvPr id="16" name="TextBox 15"/>
+              <a:rPr sz="1200" b="1">
+                <a:solidFill>
+                  <a:srgbClr val="FFFFFF"/>
+                </a:solidFill>
+                <a:latin typeface="Calibri"/>
+              </a:rPr>
+              <a:t>Personal Bests &amp; Progress</a:t>
+            </a:r>
+          </a:p>
+        </p:txBody>
+      </p:sp>
+      <p:sp>
+        <p:nvSpPr>
+          <p:cNvPr id="19" name="Rectangle 18"/>
+          <p:cNvSpPr/>
+          <p:nvPr/>
+        </p:nvSpPr>
+        <p:spPr>
+          <a:xfrm>
+            <a:off x="4251960" y="4343399"/>
+            <a:ext cx="3657600" cy="1965960"/>
+          </a:xfrm>
+          <a:prstGeom prst="rect">
+            <a:avLst/>
+          </a:prstGeom>
+          <a:solidFill>
+            <a:srgbClr val="18181B"/>
+          </a:solidFill>
+          <a:ln w="12700">
+            <a:solidFill>
+              <a:srgbClr val="DC2626"/>
+            </a:solidFill>
+          </a:ln>
+        </p:spPr>
+        <p:style>
+          <a:lnRef idx="1">
+            <a:schemeClr val="accent1"/>
+          </a:lnRef>
+          <a:fillRef idx="3">
+            <a:schemeClr val="accent1"/>
+          </a:fillRef>
+          <a:effectRef idx="2">
+            <a:schemeClr val="accent1"/>
+          </a:effectRef>
+          <a:fontRef idx="minor">
+            <a:schemeClr val="lt1"/>
+          </a:fontRef>
+        </p:style>
+        <p:txBody>
+          <a:bodyPr rtlCol="0" anchor="ctr"/>
+          <a:lstStyle/>
+          <a:p>
+            <a:pPr algn="ctr"/>
+          </a:p>
+        </p:txBody>
+      </p:sp>
+      <p:pic>
+        <p:nvPicPr>
+          <p:cNvPr id="20" name="Picture 19" descr="Screenshot_(1323)_1778766425629.png"/>
+          <p:cNvPicPr>
+            <a:picLocks noChangeAspect="1"/>
+          </p:cNvPicPr>
+          <p:nvPr/>
+        </p:nvPicPr>
+        <p:blipFill>
+          <a:blip r:embed="rId6"/>
+          <a:stretch>
+            <a:fillRect/>
+          </a:stretch>
+        </p:blipFill>
+        <p:spPr>
+          <a:xfrm>
+            <a:off x="4288536" y="4379975"/>
+            <a:ext cx="3584448" cy="1892808"/>
+          </a:xfrm>
+          <a:prstGeom prst="rect">
+            <a:avLst/>
+          </a:prstGeom>
+        </p:spPr>
+      </p:pic>
+      <p:sp>
+        <p:nvSpPr>
+          <p:cNvPr id="21" name="TextBox 20"/>
+          <p:cNvSpPr txBox="1"/>
+          <p:nvPr/>
+        </p:nvSpPr>
+        <p:spPr>
+          <a:xfrm>
+            <a:off x="4251960" y="6327647"/>
+            <a:ext cx="3657600" cy="274320"/>
+          </a:xfrm>
+          <a:prstGeom prst="rect">
+            <a:avLst/>
+          </a:prstGeom>
+          <a:noFill/>
+        </p:spPr>
+        <p:txBody>
+          <a:bodyPr wrap="square" lIns="0" rIns="0" tIns="0" bIns="0">
+            <a:spAutoFit/>
+          </a:bodyPr>
+          <a:lstStyle/>
+          <a:p>
+            <a:pPr algn="ctr"/>
+            <a:r>
+              <a:rPr sz="1200" b="1">
+                <a:solidFill>
+                  <a:srgbClr val="FFFFFF"/>
+                </a:solidFill>
+                <a:latin typeface="Calibri"/>
+              </a:rPr>
+              <a:t>Workout History</a:t>
+            </a:r>
+          </a:p>
+        </p:txBody>
+      </p:sp>
+      <p:sp>
+        <p:nvSpPr>
+          <p:cNvPr id="22" name="Rectangle 21"/>
+          <p:cNvSpPr/>
+          <p:nvPr/>
+        </p:nvSpPr>
+        <p:spPr>
+          <a:xfrm>
+            <a:off x="8001000" y="4343399"/>
+            <a:ext cx="3657600" cy="1965960"/>
+          </a:xfrm>
+          <a:prstGeom prst="rect">
+            <a:avLst/>
+          </a:prstGeom>
+          <a:solidFill>
+            <a:srgbClr val="18181B"/>
+          </a:solidFill>
+          <a:ln w="12700">
+            <a:solidFill>
+              <a:srgbClr val="DC2626"/>
+            </a:solidFill>
+          </a:ln>
+        </p:spPr>
+        <p:style>
+          <a:lnRef idx="1">
+            <a:schemeClr val="accent1"/>
+          </a:lnRef>
+          <a:fillRef idx="3">
+            <a:schemeClr val="accent1"/>
+          </a:fillRef>
+          <a:effectRef idx="2">
+            <a:schemeClr val="accent1"/>
+          </a:effectRef>
+          <a:fontRef idx="minor">
+            <a:schemeClr val="lt1"/>
+          </a:fontRef>
+        </p:style>
+        <p:txBody>
+          <a:bodyPr rtlCol="0" anchor="ctr"/>
+          <a:lstStyle/>
+          <a:p>
+            <a:pPr algn="ctr"/>
+          </a:p>
+        </p:txBody>
+      </p:sp>
+      <p:pic>
+        <p:nvPicPr>
+          <p:cNvPr id="23" name="Picture 22" descr="Screenshot_(1324)_1778766425630.png"/>
+          <p:cNvPicPr>
+            <a:picLocks noChangeAspect="1"/>
+          </p:cNvPicPr>
+          <p:nvPr/>
+        </p:nvPicPr>
+        <p:blipFill>
+          <a:blip r:embed="rId7"/>
+          <a:stretch>
+            <a:fillRect/>
+          </a:stretch>
+        </p:blipFill>
+        <p:spPr>
+          <a:xfrm>
+            <a:off x="8037576" y="4379975"/>
+            <a:ext cx="3584448" cy="1892808"/>
+          </a:xfrm>
+          <a:prstGeom prst="rect">
+            <a:avLst/>
+          </a:prstGeom>
+        </p:spPr>
+      </p:pic>
+      <p:sp>
+        <p:nvSpPr>
+          <p:cNvPr id="24" name="TextBox 23"/>
+          <p:cNvSpPr txBox="1"/>
+          <p:nvPr/>
+        </p:nvSpPr>
+        <p:spPr>
+          <a:xfrm>
+            <a:off x="8001000" y="6327647"/>
+            <a:ext cx="3657600" cy="274320"/>
+          </a:xfrm>
+          <a:prstGeom prst="rect">
+            <a:avLst/>
+          </a:prstGeom>
+          <a:noFill/>
+        </p:spPr>
+        <p:txBody>
+          <a:bodyPr wrap="square" lIns="0" rIns="0" tIns="0" bIns="0">
+            <a:spAutoFit/>
+          </a:bodyPr>
+          <a:lstStyle/>
+          <a:p>
+            <a:pPr algn="ctr"/>
+            <a:r>
+              <a:rPr sz="1200" b="1">
+                <a:solidFill>
+                  <a:srgbClr val="FFFFFF"/>
+                </a:solidFill>
+                <a:latin typeface="Calibri"/>
+              </a:rPr>
+              <a:t>Navigation Menu</a:t>
+            </a:r>
+          </a:p>
+        </p:txBody>
+      </p:sp>
+      <p:sp>
+        <p:nvSpPr>
+          <p:cNvPr id="25" name="TextBox 24"/>
           <p:cNvSpPr txBox="1"/>
           <p:nvPr/>
         </p:nvSpPr>
@@ -3943,7 +4256,7 @@
       </p:sp>
       <p:sp>
         <p:nvSpPr>
-          <p:cNvPr id="17" name="TextBox 16"/>
+          <p:cNvPr id="26" name="TextBox 25"/>
           <p:cNvSpPr txBox="1"/>
           <p:nvPr/>
         </p:nvSpPr>

</xml_diff>

<commit_message>
Update presentation with NCST and TV show details
Add Nasser Centre for Science and Technology (NCST) and "The Inventor" TV show details to the project presentation.

Replit-Commit-Author: Agent
Replit-Commit-Session-Id: 90a5a383-1c0d-45f3-a9ed-6b2404e856d1
Replit-Commit-Checkpoint-Type: full_checkpoint
Replit-Commit-Event-Id: 187bd5d2-88f2-4bd2-9ed6-9ade5666773e
Replit-Commit-Screenshot-Url: https://storage.googleapis.com/screenshot-production-us-central1/632933d6-4a17-4d84-975b-57cc17d89557/90a5a383-1c0d-45f3-a9ed-6b2404e856d1/q8MU0BM
Replit-Helium-Checkpoint-Created: true
</commit_message>
<xml_diff>
--- a/attached_assets/LAB_Project_Presentation.pptx
+++ b/attached_assets/LAB_Project_Presentation.pptx
@@ -3367,13 +3367,48 @@
           <a:p>
             <a:pPr algn="ctr"/>
             <a:r>
-              <a:rPr sz="1400" b="0">
+              <a:rPr sz="1500" b="1">
+                <a:solidFill>
+                  <a:srgbClr val="FFFFFF"/>
+                </a:solidFill>
+                <a:latin typeface="Calibri"/>
+              </a:rPr>
+              <a:t>Nasser Centre for Science and Technology  ·  NCST</a:t>
+            </a:r>
+          </a:p>
+        </p:txBody>
+      </p:sp>
+      <p:sp>
+        <p:nvSpPr>
+          <p:cNvPr id="9" name="TextBox 8"/>
+          <p:cNvSpPr txBox="1"/>
+          <p:nvPr/>
+        </p:nvSpPr>
+        <p:spPr>
+          <a:xfrm>
+            <a:off x="457200" y="5577840"/>
+            <a:ext cx="11247120" cy="365760"/>
+          </a:xfrm>
+          <a:prstGeom prst="rect">
+            <a:avLst/>
+          </a:prstGeom>
+          <a:noFill/>
+        </p:spPr>
+        <p:txBody>
+          <a:bodyPr wrap="square" lIns="0" rIns="0" tIns="0" bIns="0">
+            <a:spAutoFit/>
+          </a:bodyPr>
+          <a:lstStyle/>
+          <a:p>
+            <a:pPr algn="ctr"/>
+            <a:r>
+              <a:rPr sz="1200" b="0">
                 <a:solidFill>
                   <a:srgbClr val="A1A1AA"/>
                 </a:solidFill>
                 <a:latin typeface="Calibri"/>
               </a:rPr>
-              <a:t>Presented by Class 12.CCP</a:t>
+              <a:t>Nominated for "The Inventor"  ·  Bahrain International Channel</a:t>
             </a:r>
           </a:p>
         </p:txBody>

</xml_diff>

<commit_message>
Add QR code to the presentation's thank you slide
Add a QR code to the final slide of the PowerPoint presentation and update metadata for the presentation file.

Replit-Commit-Author: Agent
Replit-Commit-Session-Id: 90a5a383-1c0d-45f3-a9ed-6b2404e856d1
Replit-Commit-Checkpoint-Type: full_checkpoint
Replit-Commit-Event-Id: 41ae3e9c-2ffb-4f03-ad5a-73c0fe35b9bc
Replit-Commit-Screenshot-Url: https://storage.googleapis.com/screenshot-production-us-central1/632933d6-4a17-4d84-975b-57cc17d89557/90a5a383-1c0d-45f3-a9ed-6b2404e856d1/q8MU0BM
Replit-Helium-Checkpoint-Created: true
</commit_message>
<xml_diff>
--- a/attached_assets/LAB_Project_Presentation.pptx
+++ b/attached_assets/LAB_Project_Presentation.pptx
@@ -4563,6 +4563,65 @@
                 <a:latin typeface="Calibri"/>
               </a:rPr>
               <a:t>Class 12.CCP  •  Cloud Computing  •  2026</a:t>
+            </a:r>
+          </a:p>
+        </p:txBody>
+      </p:sp>
+      <p:pic>
+        <p:nvPicPr>
+          <p:cNvPr id="8" name="Picture 7" descr="LAB_1778766728646.png"/>
+          <p:cNvPicPr>
+            <a:picLocks noChangeAspect="1"/>
+          </p:cNvPicPr>
+          <p:nvPr/>
+        </p:nvPicPr>
+        <p:blipFill>
+          <a:blip r:embed="rId2"/>
+          <a:stretch>
+            <a:fillRect/>
+          </a:stretch>
+        </p:blipFill>
+        <p:spPr>
+          <a:xfrm>
+            <a:off x="5318607" y="5212080"/>
+            <a:ext cx="1554480" cy="1554480"/>
+          </a:xfrm>
+          <a:prstGeom prst="rect">
+            <a:avLst/>
+          </a:prstGeom>
+        </p:spPr>
+      </p:pic>
+      <p:sp>
+        <p:nvSpPr>
+          <p:cNvPr id="9" name="TextBox 8"/>
+          <p:cNvSpPr txBox="1"/>
+          <p:nvPr/>
+        </p:nvSpPr>
+        <p:spPr>
+          <a:xfrm>
+            <a:off x="457200" y="6812280"/>
+            <a:ext cx="11247120" cy="274320"/>
+          </a:xfrm>
+          <a:prstGeom prst="rect">
+            <a:avLst/>
+          </a:prstGeom>
+          <a:noFill/>
+        </p:spPr>
+        <p:txBody>
+          <a:bodyPr wrap="square" lIns="0" rIns="0" tIns="0" bIns="0">
+            <a:spAutoFit/>
+          </a:bodyPr>
+          <a:lstStyle/>
+          <a:p>
+            <a:pPr algn="ctr"/>
+            <a:r>
+              <a:rPr sz="1100" b="0">
+                <a:solidFill>
+                  <a:srgbClr val="A1A1AA"/>
+                </a:solidFill>
+                <a:latin typeface="Calibri"/>
+              </a:rPr>
+              <a:t>Scan to try the live app</a:t>
             </a:r>
           </a:p>
         </p:txBody>

</xml_diff>

<commit_message>
Simplify project presentation and simplify English terms
Update presentation title and simplify technical descriptions and headers in the project presentation, using simpler English.

Replit-Commit-Author: Agent
Replit-Commit-Session-Id: 90a5a383-1c0d-45f3-a9ed-6b2404e856d1
Replit-Commit-Checkpoint-Type: full_checkpoint
Replit-Commit-Event-Id: fff56033-0855-4de1-9266-4b903f7126af
Replit-Commit-Screenshot-Url: https://storage.googleapis.com/screenshot-production-us-central1/632933d6-4a17-4d84-975b-57cc17d89557/90a5a383-1c0d-45f3-a9ed-6b2404e856d1/q8MU0BM
Replit-Helium-Checkpoint-Created: true
</commit_message>
<xml_diff>
--- a/attached_assets/LAB_Project_Presentation.pptx
+++ b/attached_assets/LAB_Project_Presentation.pptx
@@ -3249,7 +3249,7 @@
                 </a:solidFill>
                 <a:latin typeface="Calibri"/>
               </a:rPr>
-              <a:t>AI-Powered Fitness Tracking &amp; Pose Detection</a:t>
+              <a:t>Smart Fitness App with AI Camera Coach</a:t>
             </a:r>
           </a:p>
         </p:txBody>
@@ -3284,7 +3284,7 @@
                 </a:solidFill>
                 <a:latin typeface="Calibri"/>
               </a:rPr>
-              <a:t>Graduation Project Report  •  2026</a:t>
+              <a:t>Graduation Project  •  2026</a:t>
             </a:r>
           </a:p>
         </p:txBody>
@@ -6951,7 +6951,7 @@
                 </a:solidFill>
                 <a:latin typeface="Calibri"/>
               </a:rPr>
-              <a:t>LAB is a full-stack web application that turns any device with a camera into a personal AI fitness coach. It uses TensorFlow.js and the MoveNet pose-detection model to track the user's body in real time, count repetitions, and grade exercise form — no wearables or sensors required.</a:t>
+              <a:t>LAB is a website that uses your phone or laptop camera to act like a personal fitness coach. It watches your body while you move, counts your reps, and tells you if your form is good or bad. You do not need a smart watch or any other device — just a camera.</a:t>
             </a:r>
           </a:p>
         </p:txBody>
@@ -7074,7 +7074,7 @@
                 </a:solidFill>
                 <a:latin typeface="Calibri"/>
               </a:rPr>
-              <a:t>Workout Tracking</a:t>
+              <a:t>Workout Tracker</a:t>
             </a:r>
           </a:p>
         </p:txBody>
@@ -7109,7 +7109,7 @@
                 </a:solidFill>
                 <a:latin typeface="Calibri"/>
               </a:rPr>
-              <a:t>Push-ups, squats, plank with live rep counting and form grading.</a:t>
+              <a:t>Do push-ups, squats, and plank. The app counts your reps and grades you.</a:t>
             </a:r>
           </a:p>
         </p:txBody>
@@ -7267,7 +7267,7 @@
                 </a:solidFill>
                 <a:latin typeface="Calibri"/>
               </a:rPr>
-              <a:t>Side-scrolling game controlled by jogging, jumping, and push-ups.</a:t>
+              <a:t>A running game you play with your body. Jog to run and jump to skip enemies.</a:t>
             </a:r>
           </a:p>
         </p:txBody>
@@ -7425,7 +7425,7 @@
                 </a:solidFill>
                 <a:latin typeface="Calibri"/>
               </a:rPr>
-              <a:t>Shadow-boxing trainer with punches, dodges, and blocks detected by camera.</a:t>
+              <a:t>A shadow-boxing trainer. Throw punches, dodge, and block using your body.</a:t>
             </a:r>
           </a:p>
         </p:txBody>
@@ -7795,7 +7795,7 @@
                 </a:solidFill>
                 <a:latin typeface="Calibri"/>
               </a:rPr>
-              <a:t>Make professional fitness coaching accessible to everyone, for free.</a:t>
+              <a:t>Give everyone a free fitness coach that anyone can use at home.</a:t>
             </a:r>
           </a:p>
           <a:p>
@@ -7820,7 +7820,7 @@
                 </a:solidFill>
                 <a:latin typeface="Calibri"/>
               </a:rPr>
-              <a:t>Replace expensive wearables and personal trainers with a phone or laptop camera.</a:t>
+              <a:t>Replace costly smart watches and gym trainers with just a camera.</a:t>
             </a:r>
           </a:p>
           <a:p>
@@ -7845,7 +7845,7 @@
                 </a:solidFill>
                 <a:latin typeface="Calibri"/>
               </a:rPr>
-              <a:t>Use AI to give real-time feedback on form, posture, and rep count.</a:t>
+              <a:t>Use AI to check your form and count your reps live, while you train.</a:t>
             </a:r>
           </a:p>
           <a:p>
@@ -7870,7 +7870,7 @@
                 </a:solidFill>
                 <a:latin typeface="Calibri"/>
               </a:rPr>
-              <a:t>Make exercise fun through gamification (Neon Run, Boxing Mode).</a:t>
+              <a:t>Make exercise fun by turning it into games like Neon Run and Boxing.</a:t>
             </a:r>
           </a:p>
         </p:txBody>
@@ -7905,7 +7905,7 @@
                 </a:solidFill>
                 <a:latin typeface="Calibri"/>
               </a:rPr>
-              <a:t>TARGET BENEFICIARIES</a:t>
+              <a:t>WHO WILL USE IT</a:t>
             </a:r>
           </a:p>
         </p:txBody>
@@ -8020,7 +8020,7 @@
                 </a:solidFill>
                 <a:latin typeface="Calibri"/>
               </a:rPr>
-              <a:t>People who can't afford gyms</a:t>
+              <a:t>People with no gym</a:t>
             </a:r>
           </a:p>
         </p:txBody>
@@ -8135,7 +8135,7 @@
                 </a:solidFill>
                 <a:latin typeface="Calibri"/>
               </a:rPr>
-              <a:t>Quick fitness breaks</a:t>
+              <a:t>Short workout breaks</a:t>
             </a:r>
           </a:p>
         </p:txBody>
@@ -8250,7 +8250,7 @@
                 </a:solidFill>
                 <a:latin typeface="Calibri"/>
               </a:rPr>
-              <a:t>Need form guidance</a:t>
+              <a:t>Need help with form</a:t>
             </a:r>
           </a:p>
         </p:txBody>
@@ -8365,7 +8365,7 @@
                 </a:solidFill>
                 <a:latin typeface="Calibri"/>
               </a:rPr>
-              <a:t>Active gameplay</a:t>
+              <a:t>Want to move and play</a:t>
             </a:r>
           </a:p>
         </p:txBody>
@@ -8703,7 +8703,7 @@
                   <a:srgbClr val="FFFFFF"/>
                 </a:solidFill>
               </a:rPr>
-              <a:t>✓  FULLY DEPLOYED &amp; LIVE IN PRODUCTION</a:t>
+              <a:t>✓  FINISHED — APP IS LIVE AND WORKING ONLINE</a:t>
             </a:r>
           </a:p>
         </p:txBody>
@@ -8738,7 +8738,7 @@
                 </a:solidFill>
                 <a:latin typeface="Calibri"/>
               </a:rPr>
-              <a:t>WHAT'S COMPLETE</a:t>
+              <a:t>WHAT IS DONE</a:t>
             </a:r>
           </a:p>
         </p:txBody>
@@ -8786,7 +8786,7 @@
                 </a:solidFill>
                 <a:latin typeface="Calibri"/>
               </a:rPr>
-              <a:t>Full React + TypeScript frontend with dark fitness theme</a:t>
+              <a:t>Full website built with a modern dark fitness design</a:t>
             </a:r>
           </a:p>
           <a:p>
@@ -8811,7 +8811,7 @@
                 </a:solidFill>
                 <a:latin typeface="Calibri"/>
               </a:rPr>
-              <a:t>Node.js + Express REST API backend with type-safe contracts</a:t>
+              <a:t>A server that handles all user requests in a safe and fast way</a:t>
             </a:r>
           </a:p>
           <a:p>
@@ -8836,7 +8836,7 @@
                 </a:solidFill>
                 <a:latin typeface="Calibri"/>
               </a:rPr>
-              <a:t>PostgreSQL database (Neon) with Drizzle ORM</a:t>
+              <a:t>An online database that saves all user data</a:t>
             </a:r>
           </a:p>
           <a:p>
@@ -8861,7 +8861,7 @@
                 </a:solidFill>
                 <a:latin typeface="Calibri"/>
               </a:rPr>
-              <a:t>Google OAuth, Microsoft OAuth, and Email/Password login (JWT-based)</a:t>
+              <a:t>Three ways to log in: Google, Microsoft, or email and password</a:t>
             </a:r>
           </a:p>
           <a:p>
@@ -8886,7 +8886,7 @@
                 </a:solidFill>
                 <a:latin typeface="Calibri"/>
               </a:rPr>
-              <a:t>Real-time pose detection for push-ups, squats, and plank</a:t>
+              <a:t>Live AI camera that tracks push-ups, squats, and plank</a:t>
             </a:r>
           </a:p>
           <a:p>
@@ -8911,7 +8911,7 @@
                 </a:solidFill>
                 <a:latin typeface="Calibri"/>
               </a:rPr>
-              <a:t>Neon Run game with 5 unlockable stages and 3 enemy types</a:t>
+              <a:t>Neon Run game with 5 levels and 3 enemy types</a:t>
             </a:r>
           </a:p>
           <a:p>
@@ -8936,7 +8936,7 @@
                 </a:solidFill>
                 <a:latin typeface="Calibri"/>
               </a:rPr>
-              <a:t>Boxing Mode with rounds, voice commands, and scoring</a:t>
+              <a:t>Boxing Mode with rounds, voice cues, and a score system</a:t>
             </a:r>
           </a:p>
           <a:p>
@@ -8961,7 +8961,7 @@
                 </a:solidFill>
                 <a:latin typeface="Calibri"/>
               </a:rPr>
-              <a:t>Admin panel with user management, audit logs, and search</a:t>
+              <a:t>Admin page to manage users, see actions, and search</a:t>
             </a:r>
           </a:p>
           <a:p>
@@ -8986,7 +8986,7 @@
                 </a:solidFill>
                 <a:latin typeface="Calibri"/>
               </a:rPr>
-              <a:t>Production deployment: Render (backend) + AWS Amplify (frontend)</a:t>
+              <a:t>App is online: server on Render, website on AWS Amplify</a:t>
             </a:r>
           </a:p>
         </p:txBody>
@@ -9396,7 +9396,7 @@
                 </a:solidFill>
                 <a:latin typeface="Calibri"/>
               </a:rPr>
-              <a:t>Cross-site cookies blocked on iOS Safari</a:t>
+              <a:t>Login problem on iPhone Safari</a:t>
             </a:r>
           </a:p>
         </p:txBody>
@@ -9431,7 +9431,7 @@
                 </a:solidFill>
                 <a:latin typeface="Calibri"/>
               </a:rPr>
-              <a:t>Frontend on Amplify and backend on Render are different domains. Safari blocked our session cookies. We solved it by switching authentication to JWT tokens stored in localStorage and sent as Authorization headers.</a:t>
+              <a:t>The website and the server are on two different web addresses. iPhone Safari blocked the login. We fixed it by using a safer login method that works on all phones.</a:t>
             </a:r>
           </a:p>
         </p:txBody>
@@ -9554,7 +9554,7 @@
                 </a:solidFill>
                 <a:latin typeface="Calibri"/>
               </a:rPr>
-              <a:t>Pose detection accuracy &amp; calibration</a:t>
+              <a:t>Making the AI camera accurate</a:t>
             </a:r>
           </a:p>
         </p:txBody>
@@ -9589,7 +9589,7 @@
                 </a:solidFill>
                 <a:latin typeface="Calibri"/>
               </a:rPr>
-              <a:t>Tuning the MoveNet model thresholds for push-up depth, squat angles, and plank alignment took many iterations to feel natural across different body types and camera angles.</a:t>
+              <a:t>It took many tries to make the AI count reps and check form correctly for different body types and camera angles.</a:t>
             </a:r>
           </a:p>
         </p:txBody>
@@ -9712,7 +9712,7 @@
                 </a:solidFill>
                 <a:latin typeface="Calibri"/>
               </a:rPr>
-              <a:t>Cloud cold starts</a:t>
+              <a:t>Slow first load on the server</a:t>
             </a:r>
           </a:p>
         </p:txBody>
@@ -9747,7 +9747,7 @@
                 </a:solidFill>
                 <a:latin typeface="Calibri"/>
               </a:rPr>
-              <a:t>Render's free tier puts the backend to sleep after 15 minutes of inactivity. First request after sleep takes 30+ seconds — we documented this and explored keep-alive strategies.</a:t>
+              <a:t>Our free server goes to sleep when nobody uses it. The first visit after sleep is slow. We had to find ways to wake it up faster.</a:t>
             </a:r>
           </a:p>
         </p:txBody>
@@ -9870,7 +9870,7 @@
                 </a:solidFill>
                 <a:latin typeface="Calibri"/>
               </a:rPr>
-              <a:t>Multi-platform deployment coordination</a:t>
+              <a:t>Linking the website, server, and database</a:t>
             </a:r>
           </a:p>
         </p:txBody>
@@ -9905,7 +9905,7 @@
                 </a:solidFill>
                 <a:latin typeface="Calibri"/>
               </a:rPr>
-              <a:t>Coordinating GitHub → Render (backend) and GitHub → Amplify (frontend) auto-deploys, plus database migrations on Neon, required careful environment-variable management across three platforms.</a:t>
+              <a:t>We had to connect three different services and make sure they all share the same settings and updates. This took a lot of testing.</a:t>
             </a:r>
           </a:p>
         </p:txBody>
@@ -10028,7 +10028,7 @@
                 </a:solidFill>
                 <a:latin typeface="Calibri"/>
               </a:rPr>
-              <a:t>Real-time game performance</a:t>
+              <a:t>Running the game and AI at the same time</a:t>
             </a:r>
           </a:p>
         </p:txBody>
@@ -10063,7 +10063,7 @@
                 </a:solidFill>
                 <a:latin typeface="Calibri"/>
               </a:rPr>
-              <a:t>Running TensorFlow.js pose detection at 30+ FPS while rendering a side-scrolling game in the same browser tab pushed performance limits. Required careful optimization of the render loop.</a:t>
+              <a:t>Playing the running game while the AI watches your body uses a lot of power. We had to make the code faster so it does not lag.</a:t>
             </a:r>
           </a:p>
         </p:txBody>
@@ -10516,7 +10516,7 @@
                 </a:solidFill>
                 <a:latin typeface="Calibri"/>
               </a:rPr>
-              <a:t>Add lunges, burpees, mountain climbers, and yoga poses to the pose detection library.</a:t>
+              <a:t>Add lunges, burpees, mountain climbers, and yoga poses to the AI camera.</a:t>
             </a:r>
           </a:p>
         </p:txBody>
@@ -10647,7 +10647,7 @@
                 </a:solidFill>
                 <a:latin typeface="Calibri"/>
               </a:rPr>
-              <a:t>Native Mobile App</a:t>
+              <a:t>Mobile App</a:t>
             </a:r>
           </a:p>
         </p:txBody>
@@ -10682,7 +10682,7 @@
                 </a:solidFill>
                 <a:latin typeface="Calibri"/>
               </a:rPr>
-              <a:t>Build a React Native / Expo version for iOS and Android with offline workout caching.</a:t>
+              <a:t>Build a real app for iPhone and Android that also works without internet.</a:t>
             </a:r>
           </a:p>
         </p:txBody>
@@ -10813,7 +10813,7 @@
                 </a:solidFill>
                 <a:latin typeface="Calibri"/>
               </a:rPr>
-              <a:t>Social &amp; Leaderboards</a:t>
+              <a:t>Friends &amp; Scores</a:t>
             </a:r>
           </a:p>
         </p:txBody>
@@ -10848,7 +10848,7 @@
                 </a:solidFill>
                 <a:latin typeface="Calibri"/>
               </a:rPr>
-              <a:t>Friend challenges, weekly leaderboards, and sharable workout summaries.</a:t>
+              <a:t>Add friend challenges, weekly score boards, and share your results.</a:t>
             </a:r>
           </a:p>
         </p:txBody>
@@ -10979,7 +10979,7 @@
                 </a:solidFill>
                 <a:latin typeface="Calibri"/>
               </a:rPr>
-              <a:t>AI Personal Trainer</a:t>
+              <a:t>Smart AI Coach</a:t>
             </a:r>
           </a:p>
         </p:txBody>
@@ -11014,7 +11014,7 @@
                 </a:solidFill>
                 <a:latin typeface="Calibri"/>
               </a:rPr>
-              <a:t>GPT-powered coach that adapts difficulty, builds custom plans, and gives voice cues.</a:t>
+              <a:t>An AI coach that builds your plan, changes the level, and talks to you.</a:t>
             </a:r>
           </a:p>
         </p:txBody>
@@ -11145,7 +11145,7 @@
                 </a:solidFill>
                 <a:latin typeface="Calibri"/>
               </a:rPr>
-              <a:t>Monetization</a:t>
+              <a:t>Paid Plans</a:t>
             </a:r>
           </a:p>
         </p:txBody>
@@ -11180,7 +11180,7 @@
                 </a:solidFill>
                 <a:latin typeface="Calibri"/>
               </a:rPr>
-              <a:t>Premium tier via RevenueCat with advanced analytics, custom programs, and meal plans.</a:t>
+              <a:t>Add a premium plan with deeper stats, custom programs, and meal plans.</a:t>
             </a:r>
           </a:p>
         </p:txBody>
@@ -11311,7 +11311,7 @@
                 </a:solidFill>
                 <a:latin typeface="Calibri"/>
               </a:rPr>
-              <a:t>Wearable Integration</a:t>
+              <a:t>Smart Watches</a:t>
             </a:r>
           </a:p>
         </p:txBody>
@@ -11346,7 +11346,7 @@
                 </a:solidFill>
                 <a:latin typeface="Calibri"/>
               </a:rPr>
-              <a:t>Sync with Apple Watch and Google Fit for heart-rate and calorie accuracy.</a:t>
+              <a:t>Connect with Apple Watch and Google Fit for heart rate and calories.</a:t>
             </a:r>
           </a:p>
         </p:txBody>

</xml_diff>